<commit_message>
Finalize verified submission deck, replay evidence and fresh-clone handoff
</commit_message>
<xml_diff>
--- a/docs/deck.pptx
+++ b/docs/deck.pptx
@@ -5619,7 +5619,7 @@
               </a:defRPr>
             </a:pPr>
             <a:r>
-              <a:t>Two predeclared task scopes of the excluded Mercy House incident. LLM-ranked baseline versus frozen source-trained selector;40 choices per arm.</a:t>
+              <a:t>Two predeclared task scopes of the excluded Mercy House incident. LLM-ranked baseline versus frozen source-trained selector; 40 choices per arm.</a:t>
             </a:r>
           </a:p>
         </p:txBody>
@@ -6263,7 +6263,7 @@
               </a:defRPr>
             </a:pPr>
             <a:r>
-              <a:t>The same grounded response bank controls NPC variation. After branches diverge, later LLM proposals may differ.</a:t>
+              <a:t>The same grounded response bank controls character variation. After branches diverge, later LLM proposals may differ.</a:t>
             </a:r>
           </a:p>
         </p:txBody>
@@ -9345,7 +9345,7 @@
               </a:defRPr>
             </a:pPr>
             <a:r>
-              <a:t>Beginner: one witnessed assault. Intermediate: two casualties and an intended target. Advanced: fabrication, custody, historical records and divided loyalties.</a:t>
+              <a:t>In the flagship case, physician Mira Sen dies while exposing old institutional records. The detective’s sister, former partner and trusted constable connect him to the inquiry, putting loyalty in conflict with proof.</a:t>
             </a:r>
           </a:p>
         </p:txBody>
@@ -15169,7 +15169,7 @@
               </a:defRPr>
             </a:pPr>
             <a:r>
-              <a:t>Earlier prototype:20,000 episodes /460 weights. Fresh source curriculum:6,000 episodes /132 weights. Language-model weights stay fixed.</a:t>
+              <a:t>Earlier prototype: 20,000 episodes / 460 weights. Fresh source curriculum: 6,000 episodes / 132 weights. Language-model weights stay fixed.</a:t>
             </a:r>
           </a:p>
         </p:txBody>

</xml_diff>

<commit_message>
Clarify interview attribution and record briefing voice validation with retained native failure
</commit_message>
<xml_diff>
--- a/docs/deck.pptx
+++ b/docs/deck.pptx
@@ -9007,7 +9007,7 @@
               </a:defRPr>
             </a:pPr>
             <a:r>
-              <a:t>120 world/runtime tests.</a:t>
+              <a:t>124 world/runtime tests.</a:t>
             </a:r>
           </a:p>
           <a:p>
@@ -9039,7 +9039,7 @@
               </a:defRPr>
             </a:pPr>
             <a:r>
-              <a:t>9 viewer tests.</a:t>
+              <a:t>14 viewer tests.</a:t>
             </a:r>
           </a:p>
           <a:p>

</xml_diff>

<commit_message>
Finalize submission walkthrough, presentation and verified provider handoff
</commit_message>
<xml_diff>
--- a/docs/deck.pptx
+++ b/docs/deck.pptx
@@ -9007,7 +9007,7 @@
               </a:defRPr>
             </a:pPr>
             <a:r>
-              <a:t>124 world/runtime tests.</a:t>
+              <a:t>127 world/runtime tests.</a:t>
             </a:r>
           </a:p>
           <a:p>
@@ -9039,7 +9039,7 @@
               </a:defRPr>
             </a:pPr>
             <a:r>
-              <a:t>14 viewer tests.</a:t>
+              <a:t>15 viewer tests.</a:t>
             </a:r>
           </a:p>
           <a:p>
@@ -9223,7 +9223,7 @@
               </a:defRPr>
             </a:pPr>
             <a:r>
-              <a:t>Open the demo without signing in. Watch a recorded case, or enter your own API key to start a live investigation.</a:t>
+              <a:t>Take the guided tour. Watch recorded cases, or choose a provider and bring your API key. Optional speech follows each exchange.</a:t>
             </a:r>
           </a:p>
         </p:txBody>
@@ -16299,7 +16299,7 @@
               </a:defRPr>
             </a:pPr>
             <a:r>
-              <a:t>Power the detective and character conversations. The viewer streams their public actions.</a:t>
+              <a:t>Power the detective and character conversations. Provider presets and custom HTTPS endpoints. Public actions stream to the viewer.</a:t>
             </a:r>
           </a:p>
         </p:txBody>

</xml_diff>

<commit_message>
Finalize validated submission materials, replay evidence and clean release package
</commit_message>
<xml_diff>
--- a/docs/deck.pptx
+++ b/docs/deck.pptx
@@ -9007,7 +9007,7 @@
               </a:defRPr>
             </a:pPr>
             <a:r>
-              <a:t>127 world/runtime tests.</a:t>
+              <a:t>137 world/runtime tests.</a:t>
             </a:r>
           </a:p>
           <a:p>
@@ -9262,7 +9262,7 @@
               </a:defRPr>
             </a:pPr>
             <a:r>
-              <a:t>A hosted beginner test scored 1.0. Difficult live cases remain unproven; a witness can refuse to disclose crucial evidence.</a:t>
+              <a:t>A hosted beginner test scored 1.0. Difficult live cases remain unproven; repeated corroborated questions now have bounded cooperation.</a:t>
             </a:r>
           </a:p>
         </p:txBody>
@@ -14261,7 +14261,7 @@
               </a:defRPr>
             </a:pPr>
             <a:r>
-              <a:t>Reassurance and relevant evidence can unlock a reluctant account. A character may still refuse.</a:t>
+              <a:t>Reassurance and evidence unlock eligible observations. Repeated legitimate requests have bounded cooperation.</a:t>
             </a:r>
           </a:p>
         </p:txBody>
@@ -14429,7 +14429,7 @@
               </a:defRPr>
             </a:pPr>
             <a:r>
-              <a:t>A separate model call writes the spoken reply using only the released recollections.</a:t>
+              <a:t>A separate model voices released recollections. A formal-account fallback records exact eligible facts.</a:t>
             </a:r>
           </a:p>
         </p:txBody>

</xml_diff>